<commit_message>
Calibrate reading-deck values on real consulting decks (0.14-draft)
read: 250 words (decision by Max), titles 20-28 pt; footnotes and
sources from 8 pt in read, update and pitch; footer items may use the
bottom margin down to 18 pt; colour roles allow a positive/negative
signal pair. Script, plan checks, patterns frame and tests updated;
all example and pattern decks re-checked without a fail.

Co-Authored-By: Claude Opus 5.5 <noreply@anthropic.com>
Claude-Session: https://claude.ai/code/session_01C3QbLz1AQ564ymywTMkJsZ
</commit_message>
<xml_diff>
--- a/examples/patterns/read.pptx
+++ b/examples/patterns/read.pptx
@@ -3011,7 +3011,7 @@
         </p:nvSpPr>
         <p:spPr>
           <a:xfrm>
-            <a:off x="11074400" y="5867400"/>
+            <a:off x="11074400" y="6172200"/>
             <a:ext cx="508000" cy="203200"/>
           </a:xfrm>
           <a:prstGeom prst="rect">
@@ -3027,7 +3027,7 @@
           <a:bodyPr/>
           <a:lstStyle>
             <a:lvl1pPr>
-              <a:defRPr sz="1000">
+              <a:defRPr sz="800">
                 <a:solidFill>
                   <a:srgbClr val="595959"/>
                 </a:solidFill>
@@ -3133,7 +3133,7 @@
         </p:nvSpPr>
         <p:spPr>
           <a:xfrm>
-            <a:off x="11074400" y="5867400"/>
+            <a:off x="11074400" y="6172200"/>
             <a:ext cx="508000" cy="203200"/>
           </a:xfrm>
           <a:prstGeom prst="rect">
@@ -3149,7 +3149,7 @@
           <a:bodyPr/>
           <a:lstStyle>
             <a:lvl1pPr>
-              <a:defRPr sz="1000">
+              <a:defRPr sz="800">
                 <a:solidFill>
                   <a:srgbClr val="595959"/>
                 </a:solidFill>
@@ -3255,7 +3255,7 @@
         </p:nvSpPr>
         <p:spPr>
           <a:xfrm>
-            <a:off x="11074400" y="5867400"/>
+            <a:off x="11074400" y="6172200"/>
             <a:ext cx="508000" cy="203200"/>
           </a:xfrm>
           <a:prstGeom prst="rect">
@@ -3271,7 +3271,7 @@
           <a:bodyPr/>
           <a:lstStyle>
             <a:lvl1pPr>
-              <a:defRPr sz="1000">
+              <a:defRPr sz="800">
                 <a:solidFill>
                   <a:srgbClr val="595959"/>
                 </a:solidFill>
@@ -3377,7 +3377,7 @@
         </p:nvSpPr>
         <p:spPr>
           <a:xfrm>
-            <a:off x="11074400" y="5867400"/>
+            <a:off x="11074400" y="6172200"/>
             <a:ext cx="508000" cy="203200"/>
           </a:xfrm>
           <a:prstGeom prst="rect">
@@ -3393,7 +3393,7 @@
           <a:bodyPr/>
           <a:lstStyle>
             <a:lvl1pPr>
-              <a:defRPr sz="1000">
+              <a:defRPr sz="800">
                 <a:solidFill>
                   <a:srgbClr val="595959"/>
                 </a:solidFill>
@@ -3573,7 +3573,7 @@
         </p:nvSpPr>
         <p:spPr>
           <a:xfrm>
-            <a:off x="11074400" y="5867400"/>
+            <a:off x="11074400" y="6172200"/>
             <a:ext cx="508000" cy="203200"/>
           </a:xfrm>
           <a:prstGeom prst="rect">
@@ -3589,7 +3589,7 @@
           <a:bodyPr/>
           <a:lstStyle>
             <a:lvl1pPr>
-              <a:defRPr sz="1000">
+              <a:defRPr sz="800">
                 <a:solidFill>
                   <a:srgbClr val="595959"/>
                 </a:solidFill>
@@ -3695,7 +3695,7 @@
         </p:nvSpPr>
         <p:spPr>
           <a:xfrm>
-            <a:off x="11074400" y="5867400"/>
+            <a:off x="11074400" y="6172200"/>
             <a:ext cx="508000" cy="203200"/>
           </a:xfrm>
           <a:prstGeom prst="rect">
@@ -3711,7 +3711,7 @@
           <a:bodyPr/>
           <a:lstStyle>
             <a:lvl1pPr>
-              <a:defRPr sz="1000">
+              <a:defRPr sz="800">
                 <a:solidFill>
                   <a:srgbClr val="595959"/>
                 </a:solidFill>
@@ -3817,7 +3817,7 @@
         </p:nvSpPr>
         <p:spPr>
           <a:xfrm>
-            <a:off x="11074400" y="5867400"/>
+            <a:off x="11074400" y="6172200"/>
             <a:ext cx="508000" cy="203200"/>
           </a:xfrm>
           <a:prstGeom prst="rect">
@@ -3833,7 +3833,7 @@
           <a:bodyPr/>
           <a:lstStyle>
             <a:lvl1pPr>
-              <a:defRPr sz="1000">
+              <a:defRPr sz="800">
                 <a:solidFill>
                   <a:srgbClr val="595959"/>
                 </a:solidFill>
@@ -3939,7 +3939,7 @@
         </p:nvSpPr>
         <p:spPr>
           <a:xfrm>
-            <a:off x="11074400" y="5867400"/>
+            <a:off x="11074400" y="6172200"/>
             <a:ext cx="508000" cy="203200"/>
           </a:xfrm>
           <a:prstGeom prst="rect">
@@ -3955,7 +3955,7 @@
           <a:bodyPr/>
           <a:lstStyle>
             <a:lvl1pPr>
-              <a:defRPr sz="1000">
+              <a:defRPr sz="800">
                 <a:solidFill>
                   <a:srgbClr val="595959"/>
                 </a:solidFill>
@@ -4061,7 +4061,7 @@
         </p:nvSpPr>
         <p:spPr>
           <a:xfrm>
-            <a:off x="11074400" y="5867400"/>
+            <a:off x="11074400" y="6172200"/>
             <a:ext cx="508000" cy="203200"/>
           </a:xfrm>
           <a:prstGeom prst="rect">
@@ -4077,7 +4077,7 @@
           <a:bodyPr/>
           <a:lstStyle>
             <a:lvl1pPr>
-              <a:defRPr sz="1000">
+              <a:defRPr sz="800">
                 <a:solidFill>
                   <a:srgbClr val="595959"/>
                 </a:solidFill>
@@ -4183,7 +4183,7 @@
         </p:nvSpPr>
         <p:spPr>
           <a:xfrm>
-            <a:off x="11074400" y="5867400"/>
+            <a:off x="11074400" y="6172200"/>
             <a:ext cx="508000" cy="203200"/>
           </a:xfrm>
           <a:prstGeom prst="rect">
@@ -4199,7 +4199,7 @@
           <a:bodyPr/>
           <a:lstStyle>
             <a:lvl1pPr>
-              <a:defRPr sz="1000">
+              <a:defRPr sz="800">
                 <a:solidFill>
                   <a:srgbClr val="595959"/>
                 </a:solidFill>
@@ -4305,7 +4305,7 @@
         </p:nvSpPr>
         <p:spPr>
           <a:xfrm>
-            <a:off x="11074400" y="5867400"/>
+            <a:off x="11074400" y="6172200"/>
             <a:ext cx="508000" cy="203200"/>
           </a:xfrm>
           <a:prstGeom prst="rect">
@@ -4321,7 +4321,7 @@
           <a:bodyPr/>
           <a:lstStyle>
             <a:lvl1pPr>
-              <a:defRPr sz="1000">
+              <a:defRPr sz="800">
                 <a:solidFill>
                   <a:srgbClr val="595959"/>
                 </a:solidFill>
@@ -4427,7 +4427,7 @@
         </p:nvSpPr>
         <p:spPr>
           <a:xfrm>
-            <a:off x="11074400" y="5867400"/>
+            <a:off x="11074400" y="6172200"/>
             <a:ext cx="508000" cy="203200"/>
           </a:xfrm>
           <a:prstGeom prst="rect">
@@ -4443,7 +4443,7 @@
           <a:bodyPr/>
           <a:lstStyle>
             <a:lvl1pPr>
-              <a:defRPr sz="1000">
+              <a:defRPr sz="800">
                 <a:solidFill>
                   <a:srgbClr val="595959"/>
                 </a:solidFill>
@@ -4500,7 +4500,7 @@
         </p:nvSpPr>
         <p:spPr>
           <a:xfrm>
-            <a:off x="11074400" y="5867400"/>
+            <a:off x="11074400" y="6172200"/>
             <a:ext cx="508000" cy="203200"/>
           </a:xfrm>
           <a:prstGeom prst="rect">
@@ -4516,7 +4516,7 @@
           <a:bodyPr/>
           <a:lstStyle>
             <a:lvl1pPr>
-              <a:defRPr sz="1000">
+              <a:defRPr sz="800">
                 <a:solidFill>
                   <a:srgbClr val="595959"/>
                 </a:solidFill>
@@ -5859,8 +5859,8 @@
         </p:nvSpPr>
         <p:spPr>
           <a:xfrm>
-            <a:off x="609600" y="5664200"/>
-            <a:ext cx="8890000" cy="228600"/>
+            <a:off x="609600" y="5969000"/>
+            <a:ext cx="8890000" cy="203200"/>
           </a:xfrm>
           <a:prstGeom prst="rect">
             <a:avLst/>
@@ -5876,7 +5876,7 @@
               <a:buNone/>
             </a:pPr>
             <a:r>
-              <a:rPr lang="en-US" sz="1000" dirty="0">
+              <a:rPr lang="en-US" sz="800" dirty="0">
                 <a:solidFill>
                   <a:srgbClr val="595959"/>
                 </a:solidFill>
@@ -5886,7 +5886,7 @@
               </a:rPr>
               <a:t>Quelle: Kostenanalyse Werk Nord, 2026 (Beispieldaten)</a:t>
             </a:r>
-            <a:endParaRPr lang="en-US" sz="1000" dirty="0"/>
+            <a:endParaRPr lang="en-US" sz="800" dirty="0"/>
           </a:p>
         </p:txBody>
       </p:sp>
@@ -5902,7 +5902,7 @@
         </p:nvSpPr>
         <p:spPr>
           <a:xfrm>
-            <a:off x="11074400" y="5867400"/>
+            <a:off x="11074400" y="6172200"/>
             <a:ext cx="508000" cy="203200"/>
           </a:xfrm>
           <a:prstGeom prst="rect">
@@ -5918,7 +5918,7 @@
           <a:bodyPr/>
           <a:lstStyle>
             <a:lvl1pPr>
-              <a:defRPr sz="1000">
+              <a:defRPr sz="800">
                 <a:solidFill>
                   <a:srgbClr val="595959"/>
                 </a:solidFill>
@@ -6486,8 +6486,8 @@
         </p:nvSpPr>
         <p:spPr>
           <a:xfrm>
-            <a:off x="609600" y="5664200"/>
-            <a:ext cx="8890000" cy="228600"/>
+            <a:off x="609600" y="5969000"/>
+            <a:ext cx="8890000" cy="203200"/>
           </a:xfrm>
           <a:prstGeom prst="rect">
             <a:avLst/>
@@ -6503,7 +6503,7 @@
               <a:buNone/>
             </a:pPr>
             <a:r>
-              <a:rPr lang="en-US" sz="1000" dirty="0">
+              <a:rPr lang="en-US" sz="800" dirty="0">
                 <a:solidFill>
                   <a:srgbClr val="595959"/>
                 </a:solidFill>
@@ -6513,7 +6513,7 @@
               </a:rPr>
               <a:t>Quelle: Projektplan, 2026 (Beispieldaten)</a:t>
             </a:r>
-            <a:endParaRPr lang="en-US" sz="1000" dirty="0"/>
+            <a:endParaRPr lang="en-US" sz="800" dirty="0"/>
           </a:p>
         </p:txBody>
       </p:sp>
@@ -6529,7 +6529,7 @@
         </p:nvSpPr>
         <p:spPr>
           <a:xfrm>
-            <a:off x="11074400" y="5867400"/>
+            <a:off x="11074400" y="6172200"/>
             <a:ext cx="508000" cy="203200"/>
           </a:xfrm>
           <a:prstGeom prst="rect">
@@ -6545,7 +6545,7 @@
           <a:bodyPr/>
           <a:lstStyle>
             <a:lvl1pPr>
-              <a:defRPr sz="1000">
+              <a:defRPr sz="800">
                 <a:solidFill>
                   <a:srgbClr val="595959"/>
                 </a:solidFill>
@@ -6942,8 +6942,8 @@
         </p:nvSpPr>
         <p:spPr>
           <a:xfrm>
-            <a:off x="609600" y="5664200"/>
-            <a:ext cx="8890000" cy="228600"/>
+            <a:off x="609600" y="5969000"/>
+            <a:ext cx="8890000" cy="203200"/>
           </a:xfrm>
           <a:prstGeom prst="rect">
             <a:avLst/>
@@ -6959,7 +6959,7 @@
               <a:buNone/>
             </a:pPr>
             <a:r>
-              <a:rPr lang="en-US" sz="1000" dirty="0">
+              <a:rPr lang="en-US" sz="800" dirty="0">
                 <a:solidFill>
                   <a:srgbClr val="595959"/>
                 </a:solidFill>
@@ -6969,7 +6969,7 @@
               </a:rPr>
               <a:t>Quelle: Interviews Werk Süd, September 2026 (Beispieldaten)</a:t>
             </a:r>
-            <a:endParaRPr lang="en-US" sz="1000" dirty="0"/>
+            <a:endParaRPr lang="en-US" sz="800" dirty="0"/>
           </a:p>
         </p:txBody>
       </p:sp>
@@ -6985,7 +6985,7 @@
         </p:nvSpPr>
         <p:spPr>
           <a:xfrm>
-            <a:off x="11074400" y="5867400"/>
+            <a:off x="11074400" y="6172200"/>
             <a:ext cx="508000" cy="203200"/>
           </a:xfrm>
           <a:prstGeom prst="rect">
@@ -7001,7 +7001,7 @@
           <a:bodyPr/>
           <a:lstStyle>
             <a:lvl1pPr>
-              <a:defRPr sz="1000">
+              <a:defRPr sz="800">
                 <a:solidFill>
                   <a:srgbClr val="595959"/>
                 </a:solidFill>
@@ -7437,8 +7437,8 @@
         </p:nvSpPr>
         <p:spPr>
           <a:xfrm>
-            <a:off x="609600" y="5664200"/>
-            <a:ext cx="8890000" cy="228600"/>
+            <a:off x="609600" y="5969000"/>
+            <a:ext cx="8890000" cy="203200"/>
           </a:xfrm>
           <a:prstGeom prst="rect">
             <a:avLst/>
@@ -7454,7 +7454,7 @@
               <a:buNone/>
             </a:pPr>
             <a:r>
-              <a:rPr lang="en-US" sz="1000" dirty="0">
+              <a:rPr lang="en-US" sz="800" dirty="0">
                 <a:solidFill>
                   <a:srgbClr val="595959"/>
                 </a:solidFill>
@@ -7464,7 +7464,7 @@
               </a:rPr>
               <a:t>Quelle: Kostenvergleich der Werke, 2026 (Beispieldaten)</a:t>
             </a:r>
-            <a:endParaRPr lang="en-US" sz="1000" dirty="0"/>
+            <a:endParaRPr lang="en-US" sz="800" dirty="0"/>
           </a:p>
         </p:txBody>
       </p:sp>
@@ -7480,7 +7480,7 @@
         </p:nvSpPr>
         <p:spPr>
           <a:xfrm>
-            <a:off x="11074400" y="5867400"/>
+            <a:off x="11074400" y="6172200"/>
             <a:ext cx="508000" cy="203200"/>
           </a:xfrm>
           <a:prstGeom prst="rect">
@@ -7496,7 +7496,7 @@
           <a:bodyPr/>
           <a:lstStyle>
             <a:lvl1pPr>
-              <a:defRPr sz="1000">
+              <a:defRPr sz="800">
                 <a:solidFill>
                   <a:srgbClr val="595959"/>
                 </a:solidFill>
@@ -7750,7 +7750,7 @@
         </p:nvSpPr>
         <p:spPr>
           <a:xfrm>
-            <a:off x="11074400" y="5867400"/>
+            <a:off x="11074400" y="6172200"/>
             <a:ext cx="508000" cy="203200"/>
           </a:xfrm>
           <a:prstGeom prst="rect">
@@ -7766,7 +7766,7 @@
           <a:bodyPr/>
           <a:lstStyle>
             <a:lvl1pPr>
-              <a:defRPr sz="1000">
+              <a:defRPr sz="800">
                 <a:solidFill>
                   <a:srgbClr val="595959"/>
                 </a:solidFill>
@@ -8097,8 +8097,8 @@
         </p:nvSpPr>
         <p:spPr>
           <a:xfrm>
-            <a:off x="609600" y="5664200"/>
-            <a:ext cx="8890000" cy="228600"/>
+            <a:off x="609600" y="5969000"/>
+            <a:ext cx="8890000" cy="203200"/>
           </a:xfrm>
           <a:prstGeom prst="rect">
             <a:avLst/>
@@ -8114,7 +8114,7 @@
               <a:buNone/>
             </a:pPr>
             <a:r>
-              <a:rPr lang="en-US" sz="1000" dirty="0">
+              <a:rPr lang="en-US" sz="800" dirty="0">
                 <a:solidFill>
                   <a:srgbClr val="595959"/>
                 </a:solidFill>
@@ -8124,7 +8124,7 @@
               </a:rPr>
               <a:t>Quelle: Kostenrechnung Werk Nord und Werk Süd, 2026 (Beispieldaten)</a:t>
             </a:r>
-            <a:endParaRPr lang="en-US" sz="1000" dirty="0"/>
+            <a:endParaRPr lang="en-US" sz="800" dirty="0"/>
           </a:p>
         </p:txBody>
       </p:sp>
@@ -8140,7 +8140,7 @@
         </p:nvSpPr>
         <p:spPr>
           <a:xfrm>
-            <a:off x="11074400" y="5867400"/>
+            <a:off x="11074400" y="6172200"/>
             <a:ext cx="508000" cy="203200"/>
           </a:xfrm>
           <a:prstGeom prst="rect">
@@ -8156,7 +8156,7 @@
           <a:bodyPr/>
           <a:lstStyle>
             <a:lvl1pPr>
-              <a:defRPr sz="1000">
+              <a:defRPr sz="800">
                 <a:solidFill>
                   <a:srgbClr val="595959"/>
                 </a:solidFill>
@@ -8527,8 +8527,8 @@
         </p:nvSpPr>
         <p:spPr>
           <a:xfrm>
-            <a:off x="609600" y="5664200"/>
-            <a:ext cx="8890000" cy="228600"/>
+            <a:off x="609600" y="5969000"/>
+            <a:ext cx="8890000" cy="203200"/>
           </a:xfrm>
           <a:prstGeom prst="rect">
             <a:avLst/>
@@ -8544,7 +8544,7 @@
               <a:buNone/>
             </a:pPr>
             <a:r>
-              <a:rPr lang="en-US" sz="1000" dirty="0">
+              <a:rPr lang="en-US" sz="800" dirty="0">
                 <a:solidFill>
                   <a:srgbClr val="595959"/>
                 </a:solidFill>
@@ -8554,7 +8554,7 @@
               </a:rPr>
               <a:t>Quelle: Energiecontrolling, 2026 (Beispieldaten)</a:t>
             </a:r>
-            <a:endParaRPr lang="en-US" sz="1000" dirty="0"/>
+            <a:endParaRPr lang="en-US" sz="800" dirty="0"/>
           </a:p>
         </p:txBody>
       </p:sp>
@@ -8570,7 +8570,7 @@
         </p:nvSpPr>
         <p:spPr>
           <a:xfrm>
-            <a:off x="11074400" y="5867400"/>
+            <a:off x="11074400" y="6172200"/>
             <a:ext cx="508000" cy="203200"/>
           </a:xfrm>
           <a:prstGeom prst="rect">
@@ -8586,7 +8586,7 @@
           <a:bodyPr/>
           <a:lstStyle>
             <a:lvl1pPr>
-              <a:defRPr sz="1000">
+              <a:defRPr sz="800">
                 <a:solidFill>
                   <a:srgbClr val="595959"/>
                 </a:solidFill>
@@ -8735,8 +8735,8 @@
         </p:nvSpPr>
         <p:spPr>
           <a:xfrm>
-            <a:off x="609600" y="5664200"/>
-            <a:ext cx="8890000" cy="228600"/>
+            <a:off x="609600" y="5969000"/>
+            <a:ext cx="8890000" cy="203200"/>
           </a:xfrm>
           <a:prstGeom prst="rect">
             <a:avLst/>
@@ -8752,7 +8752,7 @@
               <a:buNone/>
             </a:pPr>
             <a:r>
-              <a:rPr lang="en-US" sz="1000" dirty="0">
+              <a:rPr lang="en-US" sz="800" dirty="0">
                 <a:solidFill>
                   <a:srgbClr val="595959"/>
                 </a:solidFill>
@@ -8762,7 +8762,7 @@
               </a:rPr>
               <a:t>Quelle: Qualitätsberichte, 2019–2026 (Beispieldaten)</a:t>
             </a:r>
-            <a:endParaRPr lang="en-US" sz="1000" dirty="0"/>
+            <a:endParaRPr lang="en-US" sz="800" dirty="0"/>
           </a:p>
         </p:txBody>
       </p:sp>
@@ -8778,7 +8778,7 @@
         </p:nvSpPr>
         <p:spPr>
           <a:xfrm>
-            <a:off x="11074400" y="5867400"/>
+            <a:off x="11074400" y="6172200"/>
             <a:ext cx="508000" cy="203200"/>
           </a:xfrm>
           <a:prstGeom prst="rect">
@@ -8794,7 +8794,7 @@
           <a:bodyPr/>
           <a:lstStyle>
             <a:lvl1pPr>
-              <a:defRPr sz="1000">
+              <a:defRPr sz="800">
                 <a:solidFill>
                   <a:srgbClr val="595959"/>
                 </a:solidFill>
@@ -9096,8 +9096,8 @@
         </p:nvSpPr>
         <p:spPr>
           <a:xfrm>
-            <a:off x="609600" y="5664200"/>
-            <a:ext cx="8890000" cy="228600"/>
+            <a:off x="609600" y="5969000"/>
+            <a:ext cx="8890000" cy="203200"/>
           </a:xfrm>
           <a:prstGeom prst="rect">
             <a:avLst/>
@@ -9113,7 +9113,7 @@
               <a:buNone/>
             </a:pPr>
             <a:r>
-              <a:rPr lang="en-US" sz="1000" dirty="0">
+              <a:rPr lang="en-US" sz="800" dirty="0">
                 <a:solidFill>
                   <a:srgbClr val="595959"/>
                 </a:solidFill>
@@ -9123,7 +9123,7 @@
               </a:rPr>
               <a:t>Quelle: Energie- und Qualitätscontrolling, 2026 (Beispieldaten)</a:t>
             </a:r>
-            <a:endParaRPr lang="en-US" sz="1000" dirty="0"/>
+            <a:endParaRPr lang="en-US" sz="800" dirty="0"/>
           </a:p>
         </p:txBody>
       </p:sp>
@@ -9139,7 +9139,7 @@
         </p:nvSpPr>
         <p:spPr>
           <a:xfrm>
-            <a:off x="11074400" y="5867400"/>
+            <a:off x="11074400" y="6172200"/>
             <a:ext cx="508000" cy="203200"/>
           </a:xfrm>
           <a:prstGeom prst="rect">
@@ -9155,7 +9155,7 @@
           <a:bodyPr/>
           <a:lstStyle>
             <a:lvl1pPr>
-              <a:defRPr sz="1000">
+              <a:defRPr sz="800">
                 <a:solidFill>
                   <a:srgbClr val="595959"/>
                 </a:solidFill>
@@ -11083,8 +11083,8 @@
         </p:nvSpPr>
         <p:spPr>
           <a:xfrm>
-            <a:off x="609600" y="5664200"/>
-            <a:ext cx="8890000" cy="228600"/>
+            <a:off x="609600" y="5969000"/>
+            <a:ext cx="8890000" cy="203200"/>
           </a:xfrm>
           <a:prstGeom prst="rect">
             <a:avLst/>
@@ -11100,7 +11100,7 @@
               <a:buNone/>
             </a:pPr>
             <a:r>
-              <a:rPr lang="en-US" sz="1000" dirty="0">
+              <a:rPr lang="en-US" sz="800" dirty="0">
                 <a:solidFill>
                   <a:srgbClr val="595959"/>
                 </a:solidFill>
@@ -11110,7 +11110,7 @@
               </a:rPr>
               <a:t>Quelle: Kostenrechnung je Linie, 2026 (Beispieldaten)</a:t>
             </a:r>
-            <a:endParaRPr lang="en-US" sz="1000" dirty="0"/>
+            <a:endParaRPr lang="en-US" sz="800" dirty="0"/>
           </a:p>
         </p:txBody>
       </p:sp>
@@ -11126,7 +11126,7 @@
         </p:nvSpPr>
         <p:spPr>
           <a:xfrm>
-            <a:off x="11074400" y="5867400"/>
+            <a:off x="11074400" y="6172200"/>
             <a:ext cx="508000" cy="203200"/>
           </a:xfrm>
           <a:prstGeom prst="rect">
@@ -11142,7 +11142,7 @@
           <a:bodyPr/>
           <a:lstStyle>
             <a:lvl1pPr>
-              <a:defRPr sz="1000">
+              <a:defRPr sz="800">
                 <a:solidFill>
                   <a:srgbClr val="595959"/>
                 </a:solidFill>
@@ -12221,8 +12221,8 @@
         </p:nvSpPr>
         <p:spPr>
           <a:xfrm>
-            <a:off x="609600" y="5664200"/>
-            <a:ext cx="8890000" cy="228600"/>
+            <a:off x="609600" y="5969000"/>
+            <a:ext cx="8890000" cy="203200"/>
           </a:xfrm>
           <a:prstGeom prst="rect">
             <a:avLst/>
@@ -12238,7 +12238,7 @@
               <a:buNone/>
             </a:pPr>
             <a:r>
-              <a:rPr lang="en-US" sz="1000" dirty="0">
+              <a:rPr lang="en-US" sz="800" dirty="0">
                 <a:solidFill>
                   <a:srgbClr val="595959"/>
                 </a:solidFill>
@@ -12248,7 +12248,7 @@
               </a:rPr>
               <a:t>Quelle: Kostenvergleich der Werke, 2026 (Beispieldaten)</a:t>
             </a:r>
-            <a:endParaRPr lang="en-US" sz="1000" dirty="0"/>
+            <a:endParaRPr lang="en-US" sz="800" dirty="0"/>
           </a:p>
         </p:txBody>
       </p:sp>
@@ -12264,7 +12264,7 @@
         </p:nvSpPr>
         <p:spPr>
           <a:xfrm>
-            <a:off x="11074400" y="5867400"/>
+            <a:off x="11074400" y="6172200"/>
             <a:ext cx="508000" cy="203200"/>
           </a:xfrm>
           <a:prstGeom prst="rect">
@@ -12280,7 +12280,7 @@
           <a:bodyPr/>
           <a:lstStyle>
             <a:lvl1pPr>
-              <a:defRPr sz="1000">
+              <a:defRPr sz="800">
                 <a:solidFill>
                   <a:srgbClr val="595959"/>
                 </a:solidFill>
@@ -12955,8 +12955,8 @@
         </p:nvSpPr>
         <p:spPr>
           <a:xfrm>
-            <a:off x="609600" y="5664200"/>
-            <a:ext cx="8890000" cy="228600"/>
+            <a:off x="609600" y="5969000"/>
+            <a:ext cx="8890000" cy="203200"/>
           </a:xfrm>
           <a:prstGeom prst="rect">
             <a:avLst/>
@@ -12972,7 +12972,7 @@
               <a:buNone/>
             </a:pPr>
             <a:r>
-              <a:rPr lang="en-US" sz="1000" dirty="0">
+              <a:rPr lang="en-US" sz="800" dirty="0">
                 <a:solidFill>
                   <a:srgbClr val="595959"/>
                 </a:solidFill>
@@ -12982,7 +12982,7 @@
               </a:rPr>
               <a:t>Quelle: Konzept Pilot Linie 3, 2026 (Beispieldaten)</a:t>
             </a:r>
-            <a:endParaRPr lang="en-US" sz="1000" dirty="0"/>
+            <a:endParaRPr lang="en-US" sz="800" dirty="0"/>
           </a:p>
         </p:txBody>
       </p:sp>
@@ -12998,7 +12998,7 @@
         </p:nvSpPr>
         <p:spPr>
           <a:xfrm>
-            <a:off x="11074400" y="5867400"/>
+            <a:off x="11074400" y="6172200"/>
             <a:ext cx="508000" cy="203200"/>
           </a:xfrm>
           <a:prstGeom prst="rect">
@@ -13014,7 +13014,7 @@
           <a:bodyPr/>
           <a:lstStyle>
             <a:lvl1pPr>
-              <a:defRPr sz="1000">
+              <a:defRPr sz="800">
                 <a:solidFill>
                   <a:srgbClr val="595959"/>
                 </a:solidFill>

</xml_diff>